<commit_message>
Guard name-based key recovery with tests; fix product count on slide 4
- assert_product_name_maps_to_one_id: each transaction product name belongs to
  one product id (99901 placeholder excluded).
- assert_store_recovery_unambiguous: stores are only recovered via a
  (store_name, state_code) pair that maps to exactly one store. A blanket
  'name+state is unique' test would fail on valid data (Wayne, IN = 192 and 193).
- Both verified to fail on an injected error.
- Slide 4 said 17 products; there are 16 real products plus the unknown member.
  Counts are now queried from dim_product / dim_store.

Co-Authored-By: Claude Opus 5.5 <noreply@anthropic.com>
</commit_message>
<xml_diff>
--- a/deliverables/ceo_sales_review.pptx
+++ b/deliverables/ceo_sales_review.pptx
@@ -6754,7 +6754,7 @@
               </a:defRPr>
             </a:pPr>
             <a:r>
-              <a:t>uv run dbt build: 17 models, 38 tests, all passing (incl. reconciliation tests)</a:t>
+              <a:t>uv run dbt build: 17 models, 40 tests, all passing (incl. reconciliation tests)</a:t>
             </a:r>
           </a:p>
         </p:txBody>
@@ -8081,7 +8081,7 @@
               <a:defRPr sz="1500"/>
             </a:pPr>
             <a:r>
-              <a:t>• Dimensions taken out of the repeated attributes: dim_product (17 + unknown), dim_store (287 + unknown)</a:t>
+              <a:t>• Dimensions taken out of the repeated attributes: dim_product (16 + unknown), dim_store (287 + unknown)</a:t>
             </a:r>
           </a:p>
           <a:p>
@@ -8136,7 +8136,7 @@
               <a:defRPr sz="1500"/>
             </a:pPr>
             <a:r>
-              <a:t>• Tests: keys, relationships, accepted values; source -&gt; fact and fact -&gt; mart reconciliation; bridge sums exactly; assumption tests (duplicates agree, one landed cost per product-month, list price = California price)</a:t>
+              <a:t>• Tests: keys, relationships, accepted values; source -&gt; fact and fact -&gt; mart reconciliation; bridge sums exactly; assumption tests (duplicates agree, name lookups map to one id, one landed cost per product-month, list price = California price)</a:t>
             </a:r>
           </a:p>
           <a:p>

</xml_diff>